<commit_message>
feat: padronizacao exata de cores, fontes e assinaturas dos certificados conforme PDFs originais
</commit_message>
<xml_diff>
--- a/public/template-modelo1.pptx
+++ b/public/template-modelo1.pptx
@@ -3080,7 +3080,7 @@
 </file>
 
 <file path=ppt/slides/slide1.xml><?xml version="1.0" encoding="utf-8"?>
-<p:sld xmlns:a="http://schemas.openxmlformats.org/drawingml/2006/main" xmlns:p="http://schemas.openxmlformats.org/presentationml/2006/main" xmlns:r="http://schemas.openxmlformats.org/officeDocument/2006/relationships">
+<p:sld xmlns:a="http://schemas.openxmlformats.org/drawingml/2006/main" xmlns:r="http://schemas.openxmlformats.org/officeDocument/2006/relationships" xmlns:p="http://schemas.openxmlformats.org/presentationml/2006/main">
   <p:cSld>
     <p:spTree>
       <p:nvGrpSpPr>
@@ -3088,10 +3088,18 @@
         <p:cNvGrpSpPr/>
         <p:nvPr/>
       </p:nvGrpSpPr>
-      <p:grpSpPr/>
+      <p:grpSpPr>
+        <a:xfrm>
+          <a:off x="0" y="0"/>
+          <a:ext cx="0" cy="0"/>
+          <a:chOff x="0" y="0"/>
+          <a:chExt cx="0" cy="0"/>
+        </a:xfrm>
+      </p:grpSpPr>
+      <!-- Background Image -->
       <p:pic>
         <p:nvPicPr>
-          <p:cNvPr id="2" name="Picture 1" descr="m1_frente_bg.jpg"/>
+          <p:cNvPr id="2" name="Background"/>
           <p:cNvPicPr>
             <a:picLocks noChangeAspect="1"/>
           </p:cNvPicPr>
@@ -3113,9 +3121,10 @@
           </a:prstGeom>
         </p:spPr>
       </p:pic>
+      <!-- Transparent Header Banner (rId3) -->
       <p:pic>
         <p:nvPicPr>
-          <p:cNvPr id="3" name="Picture 2" descr="m1_header_transparent.png"/>
+          <p:cNvPr id="3" name="Header Transparent"/>
           <p:cNvPicPr>
             <a:picLocks noChangeAspect="1"/>
           </p:cNvPicPr>
@@ -3129,24 +3138,25 @@
         </p:blipFill>
         <p:spPr>
           <a:xfrm>
-            <a:off x="1051560" y="502920"/>
-            <a:ext cx="8586216" cy="1691640"/>
+            <a:off x="1051560" y="450000"/>
+            <a:ext cx="8586216" cy="1200000"/>
           </a:xfrm>
           <a:prstGeom prst="rect">
             <a:avLst/>
           </a:prstGeom>
         </p:spPr>
       </p:pic>
-      <p:sp>
-        <p:nvSpPr>
-          <p:cNvPr id="4" name="TextBox 3"/>
+      <!-- Justified Narrative Paragraph (Roboto #000000) -->
+      <p:sp>
+        <p:nvSpPr>
+          <p:cNvPr id="4" name="Corpo Certificado"/>
           <p:cNvSpPr txBox="1"/>
           <p:nvPr/>
         </p:nvSpPr>
         <p:spPr>
           <a:xfrm>
-            <a:off x="1097280" y="2514600"/>
-            <a:ext cx="8494776" cy="2926080"/>
+            <a:off x="1200000" y="1900000"/>
+            <a:ext cx="8289336" cy="3300000"/>
           </a:xfrm>
           <a:prstGeom prst="rect">
             <a:avLst/>
@@ -3154,71 +3164,119 @@
           <a:noFill/>
         </p:spPr>
         <p:txBody>
-          <a:bodyPr wrap="square" lIns="0" tIns="0" rIns="0" bIns="0">
-            <a:spAutoFit/>
-          </a:bodyPr>
+          <a:bodyPr vert="horz" lIns="0" tIns="0" rIns="0" bIns="0"/>
           <a:lstStyle/>
           <a:p>
             <a:pPr algn="just">
               <a:lnSpc>
-                <a:spcPct val="135000"/>
+                <a:spcPts val="1800"/>
               </a:lnSpc>
             </a:pPr>
             <a:r>
-              <a:rPr sz="1350">
+              <a:rPr lang="pt-BR" sz="1350" b="0">
                 <a:solidFill>
                   <a:srgbClr val="000000"/>
                 </a:solidFill>
-                <a:latin typeface="Arial"/>
+                <a:latin typeface="Roboto"/>
               </a:rPr>
               <a:t>A ECOSAFETY certifica que: </a:t>
             </a:r>
             <a:r>
-              <a:rPr sz="1350" b="1">
+              <a:rPr lang="pt-BR" sz="1350" b="1">
                 <a:solidFill>
                   <a:srgbClr val="000000"/>
                 </a:solidFill>
-                <a:latin typeface="Arial"/>
+                <a:latin typeface="Roboto"/>
               </a:rPr>
               <a:t>{{NOME_ALUNO}}</a:t>
             </a:r>
             <a:r>
-              <a:rPr sz="1350">
-                <a:latin typeface="Arial"/>
+              <a:rPr lang="pt-BR" sz="1350" b="0">
+                <a:solidFill>
+                  <a:srgbClr val="000000"/>
+                </a:solidFill>
+                <a:latin typeface="Roboto"/>
               </a:rPr>
               <a:t>. Portador do CPF: </a:t>
             </a:r>
             <a:r>
-              <a:rPr sz="1350" b="1">
-                <a:latin typeface="Arial"/>
+              <a:rPr lang="pt-BR" sz="1350" b="1">
+                <a:solidFill>
+                  <a:srgbClr val="000000"/>
+                </a:solidFill>
+                <a:latin typeface="Roboto"/>
               </a:rPr>
               <a:t>{{CPF}}</a:t>
             </a:r>
             <a:r>
-              <a:rPr sz="1350">
-                <a:latin typeface="Arial"/>
+              <a:rPr lang="pt-BR" sz="1350" b="0">
+                <a:solidFill>
+                  <a:srgbClr val="000000"/>
+                </a:solidFill>
+                <a:latin typeface="Roboto"/>
               </a:rPr>
-              <a:t>, completou com aprovação no período de {{DATA}} na cidade de {{LOCAL}}, o treinamento de </a:t>
-            </a:r>
-            <a:r>
-              <a:rPr sz="1350" b="1">
-                <a:latin typeface="Arial"/>
+              <a:t>, completou com aprovação no período de </a:t>
+            </a:r>
+            <a:r>
+              <a:rPr lang="pt-BR" sz="1350" b="1">
+                <a:solidFill>
+                  <a:srgbClr val="000000"/>
+                </a:solidFill>
+                <a:latin typeface="Roboto"/>
+              </a:rPr>
+              <a:t>{{DATA}}</a:t>
+            </a:r>
+            <a:r>
+              <a:rPr lang="pt-BR" sz="1350" b="0">
+                <a:solidFill>
+                  <a:srgbClr val="000000"/>
+                </a:solidFill>
+                <a:latin typeface="Roboto"/>
+              </a:rPr>
+              <a:t> na cidade de {{LOCAL}}, o treinamento de </a:t>
+            </a:r>
+            <a:r>
+              <a:rPr lang="pt-BR" sz="1350" b="1">
+                <a:solidFill>
+                  <a:srgbClr val="000000"/>
+                </a:solidFill>
+                <a:latin typeface="Roboto"/>
               </a:rPr>
               <a:t>{{CURSO}}</a:t>
             </a:r>
             <a:r>
-              <a:rPr sz="1350">
-                <a:latin typeface="Arial"/>
+              <a:rPr lang="pt-BR" sz="1350" b="0">
+                <a:solidFill>
+                  <a:srgbClr val="000000"/>
+                </a:solidFill>
+                <a:latin typeface="Roboto"/>
               </a:rPr>
-              <a:t>. {{DESCRICAO}}
-{{LOCAL}}, Brasil, {{DATA}}.</a:t>
-            </a:r>
-          </a:p>
-        </p:txBody>
-      </p:sp>
+              <a:t>. {{DESCRICAO}}</a:t>
+            </a:r>
+          </a:p>
+          <a:p>
+            <a:pPr algn="l">
+              <a:spcBfr>
+                <a:spcPts val="600"/>
+              </a:spcBfr>
+            </a:pPr>
+            <a:r>
+              <a:rPr lang="pt-BR" sz="1300" b="0">
+                <a:solidFill>
+                  <a:srgbClr val="000000"/>
+                </a:solidFill>
+                <a:latin typeface="Roboto"/>
+              </a:rPr>
+              <a:t>{{LOCAL}}, Brasil, {{DATA}}.</a:t>
+            </a:r>
+          </a:p>
+        </p:txBody>
+      </p:sp>
+      <!-- ================= 3 ASSINATURAS EM LATO BOLD COR #64268A ================= -->
+      <!-- 1. Eider Gomes (rId4) -->
       <p:pic>
         <p:nvPicPr>
-          <p:cNvPr id="5" name="Picture 4" descr="m1_sig_resp_tecnico.png"/>
+          <p:cNvPr id="5" name="Sig Eider"/>
           <p:cNvPicPr>
             <a:picLocks noChangeAspect="1"/>
           </p:cNvPicPr>
@@ -3232,101 +3290,129 @@
         </p:blipFill>
         <p:spPr>
           <a:xfrm>
-            <a:off x="1645920" y="5532120"/>
-            <a:ext cx="1463040" cy="594360"/>
+            <a:off x="1600000" y="5200000"/>
+            <a:ext cx="1600000" cy="550000"/>
           </a:xfrm>
           <a:prstGeom prst="rect">
             <a:avLst/>
           </a:prstGeom>
         </p:spPr>
       </p:pic>
-      <p:sp>
-        <p:nvSpPr>
-          <p:cNvPr id="6" name="TextBox 5"/>
-          <p:cNvSpPr txBox="1"/>
+      <!-- Eider Linha e Texto -->
+      <p:sp>
+        <p:nvSpPr>
+          <p:cNvPr id="6" name="Texto Eider"/>
+          <p:cNvSpPr/>
           <p:nvPr/>
         </p:nvSpPr>
         <p:spPr>
           <a:xfrm>
-            <a:off x="1097280" y="6126480"/>
-            <a:ext cx="2560320" cy="1005840"/>
+            <a:off x="1200000" y="5750000"/>
+            <a:ext cx="2400000" cy="1200000"/>
           </a:xfrm>
           <a:prstGeom prst="rect">
             <a:avLst/>
           </a:prstGeom>
           <a:noFill/>
+          <a:ln w="12700">
+            <a:solidFill>
+              <a:srgbClr val="64268A"/>
+            </a:solidFill>
+          </a:ln>
         </p:spPr>
         <p:txBody>
-          <a:bodyPr wrap="square">
-            <a:spAutoFit/>
-          </a:bodyPr>
-          <a:lstStyle/>
-          <a:p>
-            <a:pPr algn="ctr">
-              <a:defRPr sz="900">
-                <a:solidFill>
-                  <a:srgbClr val="4C1D95"/>
-                </a:solidFill>
-                <a:latin typeface="Arial"/>
-              </a:defRPr>
-            </a:pPr>
-            <a:r>
+          <a:bodyPr vert="horz" lIns="0" tIns="50000" rIns="0" bIns="0" anchor="t"/>
+          <a:lstStyle/>
+          <a:p>
+            <a:pPr algn="ctr"/>
+            <a:r>
+              <a:rPr lang="pt-BR" sz="950" b="1">
+                <a:solidFill>
+                  <a:srgbClr val="64268A"/>
+                </a:solidFill>
+                <a:latin typeface="Lato"/>
+              </a:rPr>
               <a:t>RESPONSAVEL TÉCNICO</a:t>
             </a:r>
-            <a:br/>
-            <a:r>
+          </a:p>
+          <a:p>
+            <a:pPr algn="ctr"/>
+            <a:r>
+              <a:rPr lang="pt-BR" sz="900" b="1">
+                <a:solidFill>
+                  <a:srgbClr val="64268A"/>
+                </a:solidFill>
+                <a:latin typeface="Lato"/>
+              </a:rPr>
               <a:t>Eider Gomes do Nascimento</a:t>
             </a:r>
-            <a:br/>
-            <a:r>
+          </a:p>
+          <a:p>
+            <a:pPr algn="ctr"/>
+            <a:r>
+              <a:rPr lang="pt-BR" sz="850" b="1">
+                <a:solidFill>
+                  <a:srgbClr val="64268A"/>
+                </a:solidFill>
+                <a:latin typeface="Lato"/>
+              </a:rPr>
               <a:t>Registro: MTE0009995/RN</a:t>
             </a:r>
           </a:p>
         </p:txBody>
       </p:sp>
-      <p:sp>
-        <p:nvSpPr>
-          <p:cNvPr id="7" name="TextBox 6"/>
-          <p:cNvSpPr txBox="1"/>
+      <!-- 2. Aluno (PENDENTE) -->
+      <p:sp>
+        <p:nvSpPr>
+          <p:cNvPr id="7" name="Texto Aluno"/>
+          <p:cNvSpPr/>
           <p:nvPr/>
         </p:nvSpPr>
         <p:spPr>
           <a:xfrm>
-            <a:off x="4069080" y="6126480"/>
-            <a:ext cx="2560320" cy="1005840"/>
+            <a:off x="4144668" y="5750000"/>
+            <a:ext cx="2400000" cy="1200000"/>
           </a:xfrm>
           <a:prstGeom prst="rect">
             <a:avLst/>
           </a:prstGeom>
           <a:noFill/>
+          <a:ln w="12700">
+            <a:solidFill>
+              <a:srgbClr val="64268A"/>
+            </a:solidFill>
+          </a:ln>
         </p:spPr>
         <p:txBody>
-          <a:bodyPr wrap="square">
-            <a:spAutoFit/>
-          </a:bodyPr>
-          <a:lstStyle/>
-          <a:p>
-            <a:pPr algn="ctr">
-              <a:defRPr sz="900">
-                <a:solidFill>
-                  <a:srgbClr val="000000"/>
-                </a:solidFill>
-                <a:latin typeface="Arial"/>
-              </a:defRPr>
-            </a:pPr>
-            <a:r>
-              <a:t>ALUNO:</a:t>
-            </a:r>
-            <a:br/>
-            <a:r>
+          <a:bodyPr vert="horz" lIns="0" tIns="50000" rIns="0" bIns="0" anchor="t"/>
+          <a:lstStyle/>
+          <a:p>
+            <a:pPr algn="ctr"/>
+            <a:r>
+              <a:rPr lang="pt-BR" sz="950" b="1">
+                <a:solidFill>
+                  <a:srgbClr val="64268A"/>
+                </a:solidFill>
+                <a:latin typeface="Lato"/>
+              </a:rPr>
+              <a:t>ALUNO: </a:t>
+            </a:r>
+            <a:r>
+              <a:rPr lang="pt-BR" sz="900" b="1">
+                <a:solidFill>
+                  <a:srgbClr val="64268A"/>
+                </a:solidFill>
+                <a:latin typeface="Lato"/>
+              </a:rPr>
               <a:t>{{NOME_ALUNO}}</a:t>
             </a:r>
           </a:p>
         </p:txBody>
       </p:sp>
+      <!-- 3. Instrutor (rId5) -->
       <p:pic>
         <p:nvPicPr>
-          <p:cNvPr id="8" name="Picture 7" descr="m1_sig_instrutor.png"/>
+          <p:cNvPr id="8" name="Sig Instrutor"/>
           <p:cNvPicPr>
             <a:picLocks noChangeAspect="1"/>
           </p:cNvPicPr>
@@ -3340,54 +3426,73 @@
         </p:blipFill>
         <p:spPr>
           <a:xfrm>
-            <a:off x="7589520" y="5532120"/>
-            <a:ext cx="1463040" cy="594360"/>
+            <a:off x="7500000" y="5200000"/>
+            <a:ext cx="1600000" cy="550000"/>
           </a:xfrm>
           <a:prstGeom prst="rect">
             <a:avLst/>
           </a:prstGeom>
         </p:spPr>
       </p:pic>
-      <p:sp>
-        <p:nvSpPr>
-          <p:cNvPr id="9" name="TextBox 8"/>
-          <p:cNvSpPr txBox="1"/>
+      <!-- Instrutor Linha e Texto -->
+      <p:sp>
+        <p:nvSpPr>
+          <p:cNvPr id="9" name="Texto Instrutor"/>
+          <p:cNvSpPr/>
           <p:nvPr/>
         </p:nvSpPr>
         <p:spPr>
           <a:xfrm>
-            <a:off x="7040880" y="6126480"/>
-            <a:ext cx="2560320" cy="1005840"/>
+            <a:off x="7100000" y="5750000"/>
+            <a:ext cx="2400000" cy="1200000"/>
           </a:xfrm>
           <a:prstGeom prst="rect">
             <a:avLst/>
           </a:prstGeom>
           <a:noFill/>
+          <a:ln w="12700">
+            <a:solidFill>
+              <a:srgbClr val="64268A"/>
+            </a:solidFill>
+          </a:ln>
         </p:spPr>
         <p:txBody>
-          <a:bodyPr wrap="square">
-            <a:spAutoFit/>
-          </a:bodyPr>
-          <a:lstStyle/>
-          <a:p>
-            <a:pPr algn="ctr">
-              <a:defRPr sz="900">
-                <a:solidFill>
-                  <a:srgbClr val="4C1D95"/>
-                </a:solidFill>
-                <a:latin typeface="Arial"/>
-              </a:defRPr>
-            </a:pPr>
-            <a:r>
+          <a:bodyPr vert="horz" lIns="0" tIns="50000" rIns="0" bIns="0" anchor="t"/>
+          <a:lstStyle/>
+          <a:p>
+            <a:pPr algn="ctr"/>
+            <a:r>
+              <a:rPr lang="pt-BR" sz="950" b="1">
+                <a:solidFill>
+                  <a:srgbClr val="64268A"/>
+                </a:solidFill>
+                <a:latin typeface="Lato"/>
+              </a:rPr>
               <a:t>INSTRUTOR:</a:t>
             </a:r>
-            <a:br/>
-            <a:r>
+          </a:p>
+          <a:p>
+            <a:pPr algn="ctr"/>
+            <a:r>
+              <a:rPr lang="pt-BR" sz="900" b="1">
+                <a:solidFill>
+                  <a:srgbClr val="64268A"/>
+                </a:solidFill>
+                <a:latin typeface="Lato"/>
+              </a:rPr>
               <a:t>{{INSTRUTOR}}</a:t>
             </a:r>
-            <a:br/>
-            <a:r>
-              <a:t>Registro: {{REGISTRO_INSTRUTOR}}</a:t>
+          </a:p>
+          <a:p>
+            <a:pPr algn="ctr"/>
+            <a:r>
+              <a:rPr lang="pt-BR" sz="850" b="1">
+                <a:solidFill>
+                  <a:srgbClr val="64268A"/>
+                </a:solidFill>
+                <a:latin typeface="Lato"/>
+              </a:rPr>
+              <a:t>{{REGISTRO_INSTRUTOR}}</a:t>
             </a:r>
           </a:p>
         </p:txBody>

</xml_diff>

<commit_message>
fix(certificados): centralizacao e melhorias no modelo 1, logos em alta definicao e qualidade 300 DPI no PDF
</commit_message>
<xml_diff>
--- a/public/template-modelo1.pptx
+++ b/public/template-modelo1.pptx
@@ -3155,8 +3155,8 @@
         </p:nvSpPr>
         <p:spPr>
           <a:xfrm>
-            <a:off x="1200000" y="1900000"/>
-            <a:ext cx="8289336" cy="3300000"/>
+            <a:off x="1200000" y="1750000"/>
+            <a:ext cx="8289336" cy="3450000"/>
           </a:xfrm>
           <a:prstGeom prst="rect">
             <a:avLst/>
@@ -3164,104 +3164,98 @@
           <a:noFill/>
         </p:spPr>
         <p:txBody>
-          <a:bodyPr vert="horz" lIns="0" tIns="0" rIns="0" bIns="0"/>
-          <a:lstStyle/>
-          <a:p>
-            <a:pPr algn="just">
-              <a:lnSpc>
-                <a:spcPts val="1800"/>
-              </a:lnSpc>
+          <a:bodyPr vert="horz" lIns="0" tIns="0" rIns="0" bIns="0" anchor="ctr"/>
+          <a:lstStyle/>
+          <!-- 1. SUBTITULO: Roboto Regular #374151 -->
+          <a:p>
+            <a:pPr algn="ctr"/>
+            <a:r>
+              <a:rPr lang="pt-BR" sz="1350" b="0">
+                <a:solidFill>
+                  <a:srgbClr val="374151"/>
+                </a:solidFill>
+                <a:latin typeface="Roboto"/>
+              </a:rPr>
+              <a:t>A ECOSAFETY certifica que:</a:t>
+            </a:r>
+          </a:p>
+          <!-- 2. NOME DO ALUNO: Roboto Bold #64268A -->
+          <a:p>
+            <a:pPr algn="ctr">
+              <a:spcBfr>
+                <a:spcPts val="500"/>
+              </a:spcBfr>
             </a:pPr>
             <a:r>
-              <a:rPr lang="pt-BR" sz="1350" b="0">
+              <a:rPr lang="pt-BR" sz="2200" b="1" spc="50">
+                <a:solidFill>
+                  <a:srgbClr val="64268A"/>
+                </a:solidFill>
+                <a:latin typeface="Roboto"/>
+              </a:rPr>
+              <a:t>{{NOME_ALUNO}}</a:t>
+            </a:r>
+          </a:p>
+          <!-- 3. TEXTO DE CONCLUSAO E CPF: Roboto Regular #000000 -->
+          <a:p>
+            <a:pPr algn="ctr">
+              <a:spcBfr>
+                <a:spcPts val="450"/>
+              </a:spcBfr>
+            </a:pPr>
+            <a:r>
+              <a:rPr lang="pt-BR" sz="1200" b="0">
                 <a:solidFill>
                   <a:srgbClr val="000000"/>
                 </a:solidFill>
                 <a:latin typeface="Roboto"/>
               </a:rPr>
-              <a:t>A ECOSAFETY certifica que: </a:t>
-            </a:r>
-            <a:r>
-              <a:rPr lang="pt-BR" sz="1350" b="1">
+              <a:t>portador(a) do CPF {{CPF}}, completou com aprovação no período de {{DATA}} na cidade de {{LOCAL}}, o treinamento de:</a:t>
+            </a:r>
+          </a:p>
+          <!-- 4. NOME DO CURSO: Roboto Bold #64268A -->
+          <a:p>
+            <a:pPr algn="ctr">
+              <a:spcBfr>
+                <a:spcPts val="500"/>
+              </a:spcBfr>
+            </a:pPr>
+            <a:r>
+              <a:rPr lang="pt-BR" sz="1600" b="1">
                 <a:solidFill>
-                  <a:srgbClr val="000000"/>
-                </a:solidFill>
-                <a:latin typeface="Roboto"/>
-              </a:rPr>
-              <a:t>{{NOME_ALUNO}}</a:t>
-            </a:r>
-            <a:r>
-              <a:rPr lang="pt-BR" sz="1350" b="0">
-                <a:solidFill>
-                  <a:srgbClr val="000000"/>
-                </a:solidFill>
-                <a:latin typeface="Roboto"/>
-              </a:rPr>
-              <a:t>. Portador do CPF: </a:t>
-            </a:r>
-            <a:r>
-              <a:rPr lang="pt-BR" sz="1350" b="1">
-                <a:solidFill>
-                  <a:srgbClr val="000000"/>
-                </a:solidFill>
-                <a:latin typeface="Roboto"/>
-              </a:rPr>
-              <a:t>{{CPF}}</a:t>
-            </a:r>
-            <a:r>
-              <a:rPr lang="pt-BR" sz="1350" b="0">
-                <a:solidFill>
-                  <a:srgbClr val="000000"/>
-                </a:solidFill>
-                <a:latin typeface="Roboto"/>
-              </a:rPr>
-              <a:t>, completou com aprovação no período de </a:t>
-            </a:r>
-            <a:r>
-              <a:rPr lang="pt-BR" sz="1350" b="1">
-                <a:solidFill>
-                  <a:srgbClr val="000000"/>
-                </a:solidFill>
-                <a:latin typeface="Roboto"/>
-              </a:rPr>
-              <a:t>{{DATA}}</a:t>
-            </a:r>
-            <a:r>
-              <a:rPr lang="pt-BR" sz="1350" b="0">
-                <a:solidFill>
-                  <a:srgbClr val="000000"/>
-                </a:solidFill>
-                <a:latin typeface="Roboto"/>
-              </a:rPr>
-              <a:t> na cidade de {{LOCAL}}, o treinamento de </a:t>
-            </a:r>
-            <a:r>
-              <a:rPr lang="pt-BR" sz="1350" b="1">
-                <a:solidFill>
-                  <a:srgbClr val="000000"/>
+                  <a:srgbClr val="64268A"/>
                 </a:solidFill>
                 <a:latin typeface="Roboto"/>
               </a:rPr>
               <a:t>{{CURSO}}</a:t>
             </a:r>
-            <a:r>
-              <a:rPr lang="pt-BR" sz="1350" b="0">
+          </a:p>
+          <!-- 5. DESCRICAO / APROVEITAMENTO: Roboto Regular #374151 -->
+          <a:p>
+            <a:pPr algn="just">
+              <a:spcBfr>
+                <a:spcPts val="400"/>
+              </a:spcBfr>
+            </a:pPr>
+            <a:r>
+              <a:rPr lang="pt-BR" sz="1050" b="0">
                 <a:solidFill>
-                  <a:srgbClr val="000000"/>
+                  <a:srgbClr val="374151"/>
                 </a:solidFill>
                 <a:latin typeface="Roboto"/>
               </a:rPr>
-              <a:t>. {{DESCRICAO}}</a:t>
-            </a:r>
-          </a:p>
-          <a:p>
-            <a:pPr algn="l">
+              <a:t>{{DESCRICAO}}</a:t>
+            </a:r>
+          </a:p>
+          <!-- 6. LOCAL E DATA: Roboto Regular #000000 -->
+          <a:p>
+            <a:pPr algn="ctr">
               <a:spcBfr>
-                <a:spcPts val="600"/>
+                <a:spcPts val="500"/>
               </a:spcBfr>
             </a:pPr>
             <a:r>
-              <a:rPr lang="pt-BR" sz="1300" b="0">
+              <a:rPr lang="pt-BR" sz="1150" b="0">
                 <a:solidFill>
                   <a:srgbClr val="000000"/>
                 </a:solidFill>

</xml_diff>